<commit_message>
Mathebox Sponsoring A4: neuer Einleitungssatz, Quelle statt Hinweis, alle fuenf Vorteile
Co-Authored-By: Claude Sonnet 5.5 <noreply@anthropic.com>
Claude-Session: https://claude.ai/code/session_0139kriXJ67p3UvpR2gsSR9G
</commit_message>
<xml_diff>
--- a/videoslides/mathebox-sponsoring-a4.pptx
+++ b/videoslides/mathebox-sponsoring-a4.pptx
@@ -1461,8 +1461,8 @@
         </p:nvSpPr>
         <p:spPr>
           <a:xfrm>
-            <a:off x="548640" y="2834640"/>
-            <a:ext cx="4480560" cy="822960"/>
+            <a:off x="548640" y="2788920"/>
+            <a:ext cx="4480560" cy="1371600"/>
           </a:xfrm>
           <a:prstGeom prst="rect">
             <a:avLst/>
@@ -1481,7 +1481,7 @@
               <a:buNone/>
             </a:pPr>
             <a:r>
-              <a:rPr lang="en-US" sz="1600" dirty="0">
+              <a:rPr lang="en-US" sz="1350" dirty="0">
                 <a:solidFill>
                   <a:srgbClr val="4A5F7A"/>
                 </a:solidFill>
@@ -1489,9 +1489,9 @@
                 <a:ea typeface="Poppins" pitchFamily="34" charset="-122"/>
                 <a:cs typeface="Poppins" pitchFamily="34" charset="-120"/>
               </a:rPr>
-              <a:t>Kostenlose Übungssoftware für den Mathematik-Unterricht in Österreich.</a:t>
-            </a:r>
-            <a:endParaRPr lang="en-US" sz="1600" dirty="0"/>
+              <a:t>Wir laden Sie ein, Hauptsponsor der Mathebox zu werden: Ihr Logo erscheint groß auf jeder Seite der kostenlosen Mathe-Übungssoftware, für 6.000 € pro Jahr.</a:t>
+            </a:r>
+            <a:endParaRPr lang="en-US" sz="1350" dirty="0"/>
           </a:p>
         </p:txBody>
       </p:sp>
@@ -1503,7 +1503,7 @@
         </p:nvSpPr>
         <p:spPr>
           <a:xfrm>
-            <a:off x="548640" y="3794760"/>
+            <a:off x="548640" y="4251960"/>
             <a:ext cx="3017520" cy="411480"/>
           </a:xfrm>
           <a:prstGeom prst="roundRect">
@@ -1530,7 +1530,7 @@
         </p:nvSpPr>
         <p:spPr>
           <a:xfrm>
-            <a:off x="548640" y="3794760"/>
+            <a:off x="548640" y="4251960"/>
             <a:ext cx="3017520" cy="411480"/>
           </a:xfrm>
           <a:prstGeom prst="rect">
@@ -1570,7 +1570,7 @@
         <p:spPr>
           <a:xfrm>
             <a:off x="5212080" y="1005840"/>
-            <a:ext cx="1801368" cy="3200400"/>
+            <a:ext cx="1801368" cy="3566160"/>
           </a:xfrm>
           <a:prstGeom prst="roundRect">
             <a:avLst>
@@ -1597,7 +1597,7 @@
         <p:spPr>
           <a:xfrm>
             <a:off x="5349240" y="1143000"/>
-            <a:ext cx="731520" cy="822960"/>
+            <a:ext cx="731520" cy="914400"/>
           </a:xfrm>
           <a:prstGeom prst="roundRect">
             <a:avLst>
@@ -1624,7 +1624,7 @@
         <p:spPr>
           <a:xfrm>
             <a:off x="5349240" y="1143000"/>
-            <a:ext cx="731520" cy="822960"/>
+            <a:ext cx="731520" cy="914400"/>
           </a:xfrm>
           <a:prstGeom prst="rect">
             <a:avLst/>
@@ -1663,7 +1663,7 @@
         <p:spPr>
           <a:xfrm>
             <a:off x="6144768" y="1143000"/>
-            <a:ext cx="731520" cy="822960"/>
+            <a:ext cx="731520" cy="914400"/>
           </a:xfrm>
           <a:prstGeom prst="roundRect">
             <a:avLst>
@@ -1690,7 +1690,7 @@
         <p:spPr>
           <a:xfrm>
             <a:off x="6144768" y="1143000"/>
-            <a:ext cx="731520" cy="822960"/>
+            <a:ext cx="731520" cy="914400"/>
           </a:xfrm>
           <a:prstGeom prst="rect">
             <a:avLst/>
@@ -1728,8 +1728,8 @@
         </p:nvSpPr>
         <p:spPr>
           <a:xfrm>
-            <a:off x="5349240" y="2057400"/>
-            <a:ext cx="731520" cy="822960"/>
+            <a:off x="5349240" y="2194560"/>
+            <a:ext cx="731520" cy="914400"/>
           </a:xfrm>
           <a:prstGeom prst="roundRect">
             <a:avLst>
@@ -1755,8 +1755,8 @@
         </p:nvSpPr>
         <p:spPr>
           <a:xfrm>
-            <a:off x="5349240" y="2057400"/>
-            <a:ext cx="731520" cy="822960"/>
+            <a:off x="5349240" y="2194560"/>
+            <a:ext cx="731520" cy="914400"/>
           </a:xfrm>
           <a:prstGeom prst="rect">
             <a:avLst/>
@@ -1794,8 +1794,8 @@
         </p:nvSpPr>
         <p:spPr>
           <a:xfrm>
-            <a:off x="6144768" y="2057400"/>
-            <a:ext cx="731520" cy="822960"/>
+            <a:off x="6144768" y="2194560"/>
+            <a:ext cx="731520" cy="914400"/>
           </a:xfrm>
           <a:prstGeom prst="roundRect">
             <a:avLst>
@@ -1821,8 +1821,8 @@
         </p:nvSpPr>
         <p:spPr>
           <a:xfrm>
-            <a:off x="6144768" y="2057400"/>
-            <a:ext cx="731520" cy="822960"/>
+            <a:off x="6144768" y="2194560"/>
+            <a:ext cx="731520" cy="914400"/>
           </a:xfrm>
           <a:prstGeom prst="rect">
             <a:avLst/>
@@ -1860,8 +1860,8 @@
         </p:nvSpPr>
         <p:spPr>
           <a:xfrm>
-            <a:off x="5349240" y="2971800"/>
-            <a:ext cx="731520" cy="822960"/>
+            <a:off x="5349240" y="3246120"/>
+            <a:ext cx="731520" cy="914400"/>
           </a:xfrm>
           <a:prstGeom prst="roundRect">
             <a:avLst>
@@ -1887,8 +1887,8 @@
         </p:nvSpPr>
         <p:spPr>
           <a:xfrm>
-            <a:off x="5349240" y="2971800"/>
-            <a:ext cx="731520" cy="822960"/>
+            <a:off x="5349240" y="3246120"/>
+            <a:ext cx="731520" cy="914400"/>
           </a:xfrm>
           <a:prstGeom prst="rect">
             <a:avLst/>
@@ -1926,8 +1926,8 @@
         </p:nvSpPr>
         <p:spPr>
           <a:xfrm>
-            <a:off x="6144768" y="2971800"/>
-            <a:ext cx="731520" cy="822960"/>
+            <a:off x="6144768" y="3246120"/>
+            <a:ext cx="731520" cy="914400"/>
           </a:xfrm>
           <a:prstGeom prst="roundRect">
             <a:avLst>
@@ -1953,8 +1953,8 @@
         </p:nvSpPr>
         <p:spPr>
           <a:xfrm>
-            <a:off x="6144768" y="2971800"/>
-            <a:ext cx="731520" cy="822960"/>
+            <a:off x="6144768" y="3246120"/>
+            <a:ext cx="731520" cy="914400"/>
           </a:xfrm>
           <a:prstGeom prst="rect">
             <a:avLst/>
@@ -1992,7 +1992,7 @@
         </p:nvSpPr>
         <p:spPr>
           <a:xfrm>
-            <a:off x="548640" y="4572000"/>
+            <a:off x="548640" y="4846320"/>
             <a:ext cx="6464808" cy="457200"/>
           </a:xfrm>
           <a:prstGeom prst="rect">
@@ -2031,12 +2031,12 @@
         </p:nvSpPr>
         <p:spPr>
           <a:xfrm>
-            <a:off x="548640" y="5074920"/>
-            <a:ext cx="6464808" cy="1691640"/>
+            <a:off x="548640" y="5349240"/>
+            <a:ext cx="6464808" cy="1554480"/>
           </a:xfrm>
           <a:prstGeom prst="roundRect">
             <a:avLst>
-              <a:gd name="adj" fmla="val 8108"/>
+              <a:gd name="adj" fmla="val 8824"/>
             </a:avLst>
           </a:prstGeom>
           <a:solidFill>
@@ -2058,8 +2058,8 @@
         </p:nvSpPr>
         <p:spPr>
           <a:xfrm>
-            <a:off x="822960" y="5166360"/>
-            <a:ext cx="5916168" cy="1508760"/>
+            <a:off x="822960" y="5394960"/>
+            <a:ext cx="5916168" cy="1463040"/>
           </a:xfrm>
           <a:prstGeom prst="rect">
             <a:avLst/>
@@ -2100,7 +2100,7 @@
         </p:nvSpPr>
         <p:spPr>
           <a:xfrm>
-            <a:off x="548640" y="7040880"/>
+            <a:off x="548640" y="7086600"/>
             <a:ext cx="6464808" cy="457200"/>
           </a:xfrm>
           <a:prstGeom prst="rect">
@@ -3632,7 +3632,7 @@
                 <a:ea typeface="Poppins" pitchFamily="34" charset="-122"/>
                 <a:cs typeface="Poppins" pitchFamily="34" charset="-120"/>
               </a:rPr>
-              <a:t>Hinweis: Die Statistik zählt auch automatisierte Zugriffe. Der Anteil echter Nutzer*innen liegt realistisch bei etwa 70 %.</a:t>
+              <a:t>Quelle: Server-Statistik der Mathebox. Die Werte enthalten auch automatisierte Zugriffe.</a:t>
             </a:r>
             <a:endParaRPr lang="en-US" sz="1050" dirty="0"/>
           </a:p>
@@ -4838,12 +4838,12 @@
         </p:nvSpPr>
         <p:spPr>
           <a:xfrm>
-            <a:off x="548640" y="3291840"/>
-            <a:ext cx="6464808" cy="640080"/>
+            <a:off x="548640" y="3246120"/>
+            <a:ext cx="6464808" cy="566928"/>
           </a:xfrm>
           <a:prstGeom prst="roundRect">
             <a:avLst>
-              <a:gd name="adj" fmla="val 21429"/>
+              <a:gd name="adj" fmla="val 24194"/>
             </a:avLst>
           </a:prstGeom>
           <a:solidFill>
@@ -4865,7 +4865,7 @@
         </p:nvSpPr>
         <p:spPr>
           <a:xfrm>
-            <a:off x="713232" y="3447288"/>
+            <a:off x="713232" y="3364992"/>
             <a:ext cx="329184" cy="329184"/>
           </a:xfrm>
           <a:prstGeom prst="ellipse">
@@ -4890,7 +4890,7 @@
         </p:nvSpPr>
         <p:spPr>
           <a:xfrm>
-            <a:off x="713232" y="3447288"/>
+            <a:off x="713232" y="3364992"/>
             <a:ext cx="329184" cy="329184"/>
           </a:xfrm>
           <a:prstGeom prst="rect">
@@ -4929,8 +4929,8 @@
         </p:nvSpPr>
         <p:spPr>
           <a:xfrm>
-            <a:off x="1188720" y="3291840"/>
-            <a:ext cx="5687568" cy="640080"/>
+            <a:off x="1188720" y="3246120"/>
+            <a:ext cx="5687568" cy="566928"/>
           </a:xfrm>
           <a:prstGeom prst="rect">
             <a:avLst/>
@@ -4971,12 +4971,12 @@
         </p:nvSpPr>
         <p:spPr>
           <a:xfrm>
-            <a:off x="548640" y="4023360"/>
-            <a:ext cx="6464808" cy="640080"/>
+            <a:off x="548640" y="3904488"/>
+            <a:ext cx="6464808" cy="566928"/>
           </a:xfrm>
           <a:prstGeom prst="roundRect">
             <a:avLst>
-              <a:gd name="adj" fmla="val 21429"/>
+              <a:gd name="adj" fmla="val 24194"/>
             </a:avLst>
           </a:prstGeom>
           <a:solidFill>
@@ -4998,7 +4998,7 @@
         </p:nvSpPr>
         <p:spPr>
           <a:xfrm>
-            <a:off x="713232" y="4178808"/>
+            <a:off x="713232" y="4023360"/>
             <a:ext cx="329184" cy="329184"/>
           </a:xfrm>
           <a:prstGeom prst="ellipse">
@@ -5023,7 +5023,7 @@
         </p:nvSpPr>
         <p:spPr>
           <a:xfrm>
-            <a:off x="713232" y="4178808"/>
+            <a:off x="713232" y="4023360"/>
             <a:ext cx="329184" cy="329184"/>
           </a:xfrm>
           <a:prstGeom prst="rect">
@@ -5062,8 +5062,8 @@
         </p:nvSpPr>
         <p:spPr>
           <a:xfrm>
-            <a:off x="1188720" y="4023360"/>
-            <a:ext cx="5687568" cy="640080"/>
+            <a:off x="1188720" y="3904488"/>
+            <a:ext cx="5687568" cy="566928"/>
           </a:xfrm>
           <a:prstGeom prst="rect">
             <a:avLst/>
@@ -5104,12 +5104,12 @@
         </p:nvSpPr>
         <p:spPr>
           <a:xfrm>
-            <a:off x="548640" y="4754880"/>
-            <a:ext cx="6464808" cy="640080"/>
+            <a:off x="548640" y="4562856"/>
+            <a:ext cx="6464808" cy="566928"/>
           </a:xfrm>
           <a:prstGeom prst="roundRect">
             <a:avLst>
-              <a:gd name="adj" fmla="val 21429"/>
+              <a:gd name="adj" fmla="val 24194"/>
             </a:avLst>
           </a:prstGeom>
           <a:solidFill>
@@ -5131,7 +5131,7 @@
         </p:nvSpPr>
         <p:spPr>
           <a:xfrm>
-            <a:off x="713232" y="4910328"/>
+            <a:off x="713232" y="4681728"/>
             <a:ext cx="329184" cy="329184"/>
           </a:xfrm>
           <a:prstGeom prst="ellipse">
@@ -5156,7 +5156,7 @@
         </p:nvSpPr>
         <p:spPr>
           <a:xfrm>
-            <a:off x="713232" y="4910328"/>
+            <a:off x="713232" y="4681728"/>
             <a:ext cx="329184" cy="329184"/>
           </a:xfrm>
           <a:prstGeom prst="rect">
@@ -5195,8 +5195,8 @@
         </p:nvSpPr>
         <p:spPr>
           <a:xfrm>
-            <a:off x="1188720" y="4754880"/>
-            <a:ext cx="5687568" cy="640080"/>
+            <a:off x="1188720" y="4562856"/>
+            <a:ext cx="5687568" cy="566928"/>
           </a:xfrm>
           <a:prstGeom prst="rect">
             <a:avLst/>
@@ -5237,12 +5237,12 @@
         </p:nvSpPr>
         <p:spPr>
           <a:xfrm>
-            <a:off x="548640" y="5486400"/>
-            <a:ext cx="6464808" cy="640080"/>
+            <a:off x="548640" y="5221224"/>
+            <a:ext cx="6464808" cy="566928"/>
           </a:xfrm>
           <a:prstGeom prst="roundRect">
             <a:avLst>
-              <a:gd name="adj" fmla="val 21429"/>
+              <a:gd name="adj" fmla="val 24194"/>
             </a:avLst>
           </a:prstGeom>
           <a:solidFill>
@@ -5264,7 +5264,7 @@
         </p:nvSpPr>
         <p:spPr>
           <a:xfrm>
-            <a:off x="713232" y="5641848"/>
+            <a:off x="713232" y="5340096"/>
             <a:ext cx="329184" cy="329184"/>
           </a:xfrm>
           <a:prstGeom prst="ellipse">
@@ -5289,7 +5289,7 @@
         </p:nvSpPr>
         <p:spPr>
           <a:xfrm>
-            <a:off x="713232" y="5641848"/>
+            <a:off x="713232" y="5340096"/>
             <a:ext cx="329184" cy="329184"/>
           </a:xfrm>
           <a:prstGeom prst="rect">
@@ -5328,8 +5328,8 @@
         </p:nvSpPr>
         <p:spPr>
           <a:xfrm>
-            <a:off x="1188720" y="5486400"/>
-            <a:ext cx="5687568" cy="640080"/>
+            <a:off x="1188720" y="5221224"/>
+            <a:ext cx="5687568" cy="566928"/>
           </a:xfrm>
           <a:prstGeom prst="rect">
             <a:avLst/>
@@ -5370,12 +5370,12 @@
         </p:nvSpPr>
         <p:spPr>
           <a:xfrm>
-            <a:off x="548640" y="6217920"/>
-            <a:ext cx="6464808" cy="640080"/>
+            <a:off x="548640" y="5879592"/>
+            <a:ext cx="6464808" cy="566928"/>
           </a:xfrm>
           <a:prstGeom prst="roundRect">
             <a:avLst>
-              <a:gd name="adj" fmla="val 21429"/>
+              <a:gd name="adj" fmla="val 24194"/>
             </a:avLst>
           </a:prstGeom>
           <a:solidFill>
@@ -5397,7 +5397,7 @@
         </p:nvSpPr>
         <p:spPr>
           <a:xfrm>
-            <a:off x="713232" y="6373368"/>
+            <a:off x="713232" y="5998464"/>
             <a:ext cx="329184" cy="329184"/>
           </a:xfrm>
           <a:prstGeom prst="ellipse">
@@ -5422,7 +5422,7 @@
         </p:nvSpPr>
         <p:spPr>
           <a:xfrm>
-            <a:off x="713232" y="6373368"/>
+            <a:off x="713232" y="5998464"/>
             <a:ext cx="329184" cy="329184"/>
           </a:xfrm>
           <a:prstGeom prst="rect">
@@ -5461,8 +5461,8 @@
         </p:nvSpPr>
         <p:spPr>
           <a:xfrm>
-            <a:off x="1188720" y="6217920"/>
-            <a:ext cx="5687568" cy="640080"/>
+            <a:off x="1188720" y="5879592"/>
+            <a:ext cx="5687568" cy="566928"/>
           </a:xfrm>
           <a:prstGeom prst="rect">
             <a:avLst/>
@@ -5503,12 +5503,12 @@
         </p:nvSpPr>
         <p:spPr>
           <a:xfrm>
-            <a:off x="548640" y="6949440"/>
-            <a:ext cx="6464808" cy="640080"/>
+            <a:off x="548640" y="6537960"/>
+            <a:ext cx="6464808" cy="566928"/>
           </a:xfrm>
           <a:prstGeom prst="roundRect">
             <a:avLst>
-              <a:gd name="adj" fmla="val 21429"/>
+              <a:gd name="adj" fmla="val 24194"/>
             </a:avLst>
           </a:prstGeom>
           <a:solidFill>
@@ -5530,7 +5530,7 @@
         </p:nvSpPr>
         <p:spPr>
           <a:xfrm>
-            <a:off x="713232" y="7104888"/>
+            <a:off x="713232" y="6656832"/>
             <a:ext cx="329184" cy="329184"/>
           </a:xfrm>
           <a:prstGeom prst="ellipse">
@@ -5555,7 +5555,7 @@
         </p:nvSpPr>
         <p:spPr>
           <a:xfrm>
-            <a:off x="713232" y="7104888"/>
+            <a:off x="713232" y="6656832"/>
             <a:ext cx="329184" cy="329184"/>
           </a:xfrm>
           <a:prstGeom prst="rect">
@@ -5594,8 +5594,8 @@
         </p:nvSpPr>
         <p:spPr>
           <a:xfrm>
-            <a:off x="1188720" y="6949440"/>
-            <a:ext cx="5687568" cy="640080"/>
+            <a:off x="1188720" y="6537960"/>
+            <a:ext cx="5687568" cy="566928"/>
           </a:xfrm>
           <a:prstGeom prst="rect">
             <a:avLst/>
@@ -5636,7 +5636,7 @@
         </p:nvSpPr>
         <p:spPr>
           <a:xfrm>
-            <a:off x="548640" y="7863840"/>
+            <a:off x="548640" y="7269480"/>
             <a:ext cx="6464808" cy="457200"/>
           </a:xfrm>
           <a:prstGeom prst="rect">
@@ -5675,12 +5675,12 @@
         </p:nvSpPr>
         <p:spPr>
           <a:xfrm>
-            <a:off x="548640" y="8412480"/>
-            <a:ext cx="3154680" cy="841248"/>
+            <a:off x="548640" y="7772400"/>
+            <a:ext cx="3154680" cy="777240"/>
           </a:xfrm>
           <a:prstGeom prst="roundRect">
             <a:avLst>
-              <a:gd name="adj" fmla="val 16304"/>
+              <a:gd name="adj" fmla="val 17647"/>
             </a:avLst>
           </a:prstGeom>
           <a:solidFill>
@@ -5702,8 +5702,8 @@
         </p:nvSpPr>
         <p:spPr>
           <a:xfrm>
-            <a:off x="777240" y="8549640"/>
-            <a:ext cx="2788920" cy="438912"/>
+            <a:off x="777240" y="7845552"/>
+            <a:ext cx="2697480" cy="320040"/>
           </a:xfrm>
           <a:prstGeom prst="rect">
             <a:avLst/>
@@ -5719,7 +5719,7 @@
               <a:buNone/>
             </a:pPr>
             <a:r>
-              <a:rPr lang="en-US" sz="1400" b="1" dirty="0">
+              <a:rPr lang="en-US" sz="1300" b="1" dirty="0">
                 <a:solidFill>
                   <a:srgbClr val="DCEBFA"/>
                 </a:solidFill>
@@ -5729,7 +5729,7 @@
               </a:rPr>
               <a:t>Gezielte Reichweite</a:t>
             </a:r>
-            <a:endParaRPr lang="en-US" sz="1400" dirty="0"/>
+            <a:endParaRPr lang="en-US" sz="1300" dirty="0"/>
           </a:p>
         </p:txBody>
       </p:sp>
@@ -5741,8 +5741,8 @@
         </p:nvSpPr>
         <p:spPr>
           <a:xfrm>
-            <a:off x="777240" y="9070848"/>
-            <a:ext cx="2697480" cy="109728"/>
+            <a:off x="777240" y="8183880"/>
+            <a:ext cx="2697480" cy="329184"/>
           </a:xfrm>
           <a:prstGeom prst="rect">
             <a:avLst/>
@@ -5755,12 +5755,20 @@
           <a:lstStyle/>
           <a:p>
             <a:pPr indent="0" marL="0">
-              <a:lnSpc>
-                <a:spcPct val="115000"/>
-              </a:lnSpc>
-              <a:buNone/>
-            </a:pPr>
-            <a:endParaRPr lang="en-US" sz="1150" dirty="0"/>
+              <a:buNone/>
+            </a:pPr>
+            <a:r>
+              <a:rPr lang="en-US" sz="950" dirty="0">
+                <a:solidFill>
+                  <a:srgbClr val="B5CCEC"/>
+                </a:solidFill>
+                <a:latin typeface="Poppins" pitchFamily="34" charset="0"/>
+                <a:ea typeface="Poppins" pitchFamily="34" charset="-122"/>
+                <a:cs typeface="Poppins" pitchFamily="34" charset="-120"/>
+              </a:rPr>
+              <a:t>Rund 100.000 Besuche pro Jahr aus Schule und Elternhaus.</a:t>
+            </a:r>
+            <a:endParaRPr lang="en-US" sz="950" dirty="0"/>
           </a:p>
         </p:txBody>
       </p:sp>
@@ -5772,12 +5780,12 @@
         </p:nvSpPr>
         <p:spPr>
           <a:xfrm>
-            <a:off x="3858768" y="8412480"/>
-            <a:ext cx="3154680" cy="841248"/>
+            <a:off x="3858768" y="7772400"/>
+            <a:ext cx="3154680" cy="777240"/>
           </a:xfrm>
           <a:prstGeom prst="roundRect">
             <a:avLst>
-              <a:gd name="adj" fmla="val 16304"/>
+              <a:gd name="adj" fmla="val 17647"/>
             </a:avLst>
           </a:prstGeom>
           <a:solidFill>
@@ -5799,8 +5807,8 @@
         </p:nvSpPr>
         <p:spPr>
           <a:xfrm>
-            <a:off x="4087368" y="8549640"/>
-            <a:ext cx="2788920" cy="438912"/>
+            <a:off x="4087368" y="7845552"/>
+            <a:ext cx="2697480" cy="320040"/>
           </a:xfrm>
           <a:prstGeom prst="rect">
             <a:avLst/>
@@ -5816,7 +5824,7 @@
               <a:buNone/>
             </a:pPr>
             <a:r>
-              <a:rPr lang="en-US" sz="1400" b="1" dirty="0">
+              <a:rPr lang="en-US" sz="1300" b="1" dirty="0">
                 <a:solidFill>
                   <a:srgbClr val="DCEBFA"/>
                 </a:solidFill>
@@ -5826,7 +5834,7 @@
               </a:rPr>
               <a:t>Hohe Verweildauer</a:t>
             </a:r>
-            <a:endParaRPr lang="en-US" sz="1400" dirty="0"/>
+            <a:endParaRPr lang="en-US" sz="1300" dirty="0"/>
           </a:p>
         </p:txBody>
       </p:sp>
@@ -5838,8 +5846,8 @@
         </p:nvSpPr>
         <p:spPr>
           <a:xfrm>
-            <a:off x="4087368" y="9070848"/>
-            <a:ext cx="2697480" cy="109728"/>
+            <a:off x="4087368" y="8183880"/>
+            <a:ext cx="2697480" cy="329184"/>
           </a:xfrm>
           <a:prstGeom prst="rect">
             <a:avLst/>
@@ -5852,12 +5860,20 @@
           <a:lstStyle/>
           <a:p>
             <a:pPr indent="0" marL="0">
-              <a:lnSpc>
-                <a:spcPct val="115000"/>
-              </a:lnSpc>
-              <a:buNone/>
-            </a:pPr>
-            <a:endParaRPr lang="en-US" sz="1150" dirty="0"/>
+              <a:buNone/>
+            </a:pPr>
+            <a:r>
+              <a:rPr lang="en-US" sz="950" dirty="0">
+                <a:solidFill>
+                  <a:srgbClr val="B5CCEC"/>
+                </a:solidFill>
+                <a:latin typeface="Poppins" pitchFamily="34" charset="0"/>
+                <a:ea typeface="Poppins" pitchFamily="34" charset="-122"/>
+                <a:cs typeface="Poppins" pitchFamily="34" charset="-120"/>
+              </a:rPr>
+              <a:t>Etwa 14 Seiten pro Besuch, Logo bei jeder sichtbar.</a:t>
+            </a:r>
+            <a:endParaRPr lang="en-US" sz="950" dirty="0"/>
           </a:p>
         </p:txBody>
       </p:sp>
@@ -5869,12 +5885,12 @@
         </p:nvSpPr>
         <p:spPr>
           <a:xfrm>
-            <a:off x="548640" y="9326880"/>
-            <a:ext cx="3154680" cy="841248"/>
+            <a:off x="548640" y="8641080"/>
+            <a:ext cx="3154680" cy="777240"/>
           </a:xfrm>
           <a:prstGeom prst="roundRect">
             <a:avLst>
-              <a:gd name="adj" fmla="val 16304"/>
+              <a:gd name="adj" fmla="val 17647"/>
             </a:avLst>
           </a:prstGeom>
           <a:solidFill>
@@ -5896,8 +5912,8 @@
         </p:nvSpPr>
         <p:spPr>
           <a:xfrm>
-            <a:off x="777240" y="9464040"/>
-            <a:ext cx="2788920" cy="438912"/>
+            <a:off x="777240" y="8714232"/>
+            <a:ext cx="2697480" cy="320040"/>
           </a:xfrm>
           <a:prstGeom prst="rect">
             <a:avLst/>
@@ -5913,7 +5929,7 @@
               <a:buNone/>
             </a:pPr>
             <a:r>
-              <a:rPr lang="en-US" sz="1400" b="1" dirty="0">
+              <a:rPr lang="en-US" sz="1300" b="1" dirty="0">
                 <a:solidFill>
                   <a:srgbClr val="DCEBFA"/>
                 </a:solidFill>
@@ -5923,7 +5939,7 @@
               </a:rPr>
               <a:t>Positives Umfeld</a:t>
             </a:r>
-            <a:endParaRPr lang="en-US" sz="1400" dirty="0"/>
+            <a:endParaRPr lang="en-US" sz="1300" dirty="0"/>
           </a:p>
         </p:txBody>
       </p:sp>
@@ -5935,8 +5951,8 @@
         </p:nvSpPr>
         <p:spPr>
           <a:xfrm>
-            <a:off x="777240" y="9985248"/>
-            <a:ext cx="2697480" cy="109728"/>
+            <a:off x="777240" y="9052560"/>
+            <a:ext cx="2697480" cy="329184"/>
           </a:xfrm>
           <a:prstGeom prst="rect">
             <a:avLst/>
@@ -5949,12 +5965,20 @@
           <a:lstStyle/>
           <a:p>
             <a:pPr indent="0" marL="0">
-              <a:lnSpc>
-                <a:spcPct val="115000"/>
-              </a:lnSpc>
-              <a:buNone/>
-            </a:pPr>
-            <a:endParaRPr lang="en-US" sz="1150" dirty="0"/>
+              <a:buNone/>
+            </a:pPr>
+            <a:r>
+              <a:rPr lang="en-US" sz="950" dirty="0">
+                <a:solidFill>
+                  <a:srgbClr val="B5CCEC"/>
+                </a:solidFill>
+                <a:latin typeface="Poppins" pitchFamily="34" charset="0"/>
+                <a:ea typeface="Poppins" pitchFamily="34" charset="-122"/>
+                <a:cs typeface="Poppins" pitchFamily="34" charset="-120"/>
+              </a:rPr>
+              <a:t>Kostenlos, werbefrei, ohne Registrierung: Vertrauen färbt ab.</a:t>
+            </a:r>
+            <a:endParaRPr lang="en-US" sz="950" dirty="0"/>
           </a:p>
         </p:txBody>
       </p:sp>
@@ -5966,12 +5990,12 @@
         </p:nvSpPr>
         <p:spPr>
           <a:xfrm>
-            <a:off x="3858768" y="9326880"/>
-            <a:ext cx="3154680" cy="841248"/>
+            <a:off x="3858768" y="8641080"/>
+            <a:ext cx="3154680" cy="777240"/>
           </a:xfrm>
           <a:prstGeom prst="roundRect">
             <a:avLst>
-              <a:gd name="adj" fmla="val 16304"/>
+              <a:gd name="adj" fmla="val 17647"/>
             </a:avLst>
           </a:prstGeom>
           <a:solidFill>
@@ -5993,8 +6017,8 @@
         </p:nvSpPr>
         <p:spPr>
           <a:xfrm>
-            <a:off x="4087368" y="9464040"/>
-            <a:ext cx="2788920" cy="438912"/>
+            <a:off x="4087368" y="8714232"/>
+            <a:ext cx="2697480" cy="320040"/>
           </a:xfrm>
           <a:prstGeom prst="rect">
             <a:avLst/>
@@ -6010,7 +6034,7 @@
               <a:buNone/>
             </a:pPr>
             <a:r>
-              <a:rPr lang="en-US" sz="1400" b="1" dirty="0">
+              <a:rPr lang="en-US" sz="1300" b="1" dirty="0">
                 <a:solidFill>
                   <a:srgbClr val="DCEBFA"/>
                 </a:solidFill>
@@ -6020,7 +6044,7 @@
               </a:rPr>
               <a:t>Dauerhafte Präsenz</a:t>
             </a:r>
-            <a:endParaRPr lang="en-US" sz="1400" dirty="0"/>
+            <a:endParaRPr lang="en-US" sz="1300" dirty="0"/>
           </a:p>
         </p:txBody>
       </p:sp>
@@ -6032,8 +6056,8 @@
         </p:nvSpPr>
         <p:spPr>
           <a:xfrm>
-            <a:off x="4087368" y="9985248"/>
-            <a:ext cx="2697480" cy="109728"/>
+            <a:off x="4087368" y="9052560"/>
+            <a:ext cx="2697480" cy="329184"/>
           </a:xfrm>
           <a:prstGeom prst="rect">
             <a:avLst/>
@@ -6046,25 +6070,99 @@
           <a:lstStyle/>
           <a:p>
             <a:pPr indent="0" marL="0">
-              <a:lnSpc>
-                <a:spcPct val="115000"/>
-              </a:lnSpc>
-              <a:buNone/>
-            </a:pPr>
-            <a:endParaRPr lang="en-US" sz="1150" dirty="0"/>
-          </a:p>
-        </p:txBody>
-      </p:sp>
-      <p:sp>
-        <p:nvSpPr>
-          <p:cNvPr id="43" name="Text 40"/>
-          <p:cNvSpPr txBox="1"/>
-          <p:nvPr/>
-        </p:nvSpPr>
-        <p:spPr>
-          <a:xfrm>
-            <a:off x="777240" y="8869680"/>
-            <a:ext cx="2697480" cy="365760"/>
+              <a:buNone/>
+            </a:pPr>
+            <a:r>
+              <a:rPr lang="en-US" sz="950" dirty="0">
+                <a:solidFill>
+                  <a:srgbClr val="B5CCEC"/>
+                </a:solidFill>
+                <a:latin typeface="Poppins" pitchFamily="34" charset="0"/>
+                <a:ea typeface="Poppins" pitchFamily="34" charset="-122"/>
+                <a:cs typeface="Poppins" pitchFamily="34" charset="-120"/>
+              </a:rPr>
+              <a:t>Logo auf allen Seiten, während der gesamten Laufzeit.</a:t>
+            </a:r>
+            <a:endParaRPr lang="en-US" sz="950" dirty="0"/>
+          </a:p>
+        </p:txBody>
+      </p:sp>
+      <p:sp>
+        <p:nvSpPr>
+          <p:cNvPr id="43" name="Shape 40"/>
+          <p:cNvSpPr/>
+          <p:nvPr/>
+        </p:nvSpPr>
+        <p:spPr>
+          <a:xfrm>
+            <a:off x="548640" y="9509760"/>
+            <a:ext cx="6464808" cy="777240"/>
+          </a:xfrm>
+          <a:prstGeom prst="roundRect">
+            <a:avLst>
+              <a:gd name="adj" fmla="val 17647"/>
+            </a:avLst>
+          </a:prstGeom>
+          <a:solidFill>
+            <a:srgbClr val="1B3D75"/>
+          </a:solidFill>
+          <a:ln w="15875">
+            <a:solidFill>
+              <a:srgbClr val="3B66A8"/>
+            </a:solidFill>
+            <a:prstDash val="solid"/>
+          </a:ln>
+        </p:spPr>
+      </p:sp>
+      <p:sp>
+        <p:nvSpPr>
+          <p:cNvPr id="44" name="Text 41"/>
+          <p:cNvSpPr txBox="1"/>
+          <p:nvPr/>
+        </p:nvSpPr>
+        <p:spPr>
+          <a:xfrm>
+            <a:off x="777240" y="9582912"/>
+            <a:ext cx="6007608" cy="320040"/>
+          </a:xfrm>
+          <a:prstGeom prst="rect">
+            <a:avLst/>
+          </a:prstGeom>
+          <a:noFill/>
+          <a:ln/>
+        </p:spPr>
+        <p:txBody>
+          <a:bodyPr wrap="square" lIns="0" tIns="0" rIns="0" bIns="0" rtlCol="0" anchor="ctr"/>
+          <a:lstStyle/>
+          <a:p>
+            <a:pPr indent="0" marL="0">
+              <a:buNone/>
+            </a:pPr>
+            <a:r>
+              <a:rPr lang="en-US" sz="1300" b="1" dirty="0">
+                <a:solidFill>
+                  <a:srgbClr val="DCEBFA"/>
+                </a:solidFill>
+                <a:latin typeface="Poppins" pitchFamily="34" charset="0"/>
+                <a:ea typeface="Poppins" pitchFamily="34" charset="-122"/>
+                <a:cs typeface="Poppins" pitchFamily="34" charset="-120"/>
+              </a:rPr>
+              <a:t>Sichtbarer Beitrag</a:t>
+            </a:r>
+            <a:endParaRPr lang="en-US" sz="1300" dirty="0"/>
+          </a:p>
+        </p:txBody>
+      </p:sp>
+      <p:sp>
+        <p:nvSpPr>
+          <p:cNvPr id="45" name="Text 42"/>
+          <p:cNvSpPr txBox="1"/>
+          <p:nvPr/>
+        </p:nvSpPr>
+        <p:spPr>
+          <a:xfrm>
+            <a:off x="777240" y="9921240"/>
+            <a:ext cx="6007608" cy="329184"/>
           </a:xfrm>
           <a:prstGeom prst="rect">
             <a:avLst/>
@@ -6088,124 +6186,7 @@
                 <a:ea typeface="Poppins" pitchFamily="34" charset="-122"/>
                 <a:cs typeface="Poppins" pitchFamily="34" charset="-120"/>
               </a:rPr>
-              <a:t>Rund 100.000 Besuche pro Jahr aus Schule und Elternhaus.</a:t>
-            </a:r>
-            <a:endParaRPr lang="en-US" sz="950" dirty="0"/>
-          </a:p>
-        </p:txBody>
-      </p:sp>
-      <p:sp>
-        <p:nvSpPr>
-          <p:cNvPr id="44" name="Text 41"/>
-          <p:cNvSpPr txBox="1"/>
-          <p:nvPr/>
-        </p:nvSpPr>
-        <p:spPr>
-          <a:xfrm>
-            <a:off x="4087368" y="8869680"/>
-            <a:ext cx="2697480" cy="365760"/>
-          </a:xfrm>
-          <a:prstGeom prst="rect">
-            <a:avLst/>
-          </a:prstGeom>
-          <a:noFill/>
-          <a:ln/>
-        </p:spPr>
-        <p:txBody>
-          <a:bodyPr wrap="square" lIns="0" tIns="0" rIns="0" bIns="0" rtlCol="0" anchor="t"/>
-          <a:lstStyle/>
-          <a:p>
-            <a:pPr indent="0" marL="0">
-              <a:buNone/>
-            </a:pPr>
-            <a:r>
-              <a:rPr lang="en-US" sz="950" dirty="0">
-                <a:solidFill>
-                  <a:srgbClr val="B5CCEC"/>
-                </a:solidFill>
-                <a:latin typeface="Poppins" pitchFamily="34" charset="0"/>
-                <a:ea typeface="Poppins" pitchFamily="34" charset="-122"/>
-                <a:cs typeface="Poppins" pitchFamily="34" charset="-120"/>
-              </a:rPr>
-              <a:t>Etwa 14 Seiten pro Besuch, Logo bei jeder sichtbar.</a:t>
-            </a:r>
-            <a:endParaRPr lang="en-US" sz="950" dirty="0"/>
-          </a:p>
-        </p:txBody>
-      </p:sp>
-      <p:sp>
-        <p:nvSpPr>
-          <p:cNvPr id="45" name="Text 42"/>
-          <p:cNvSpPr txBox="1"/>
-          <p:nvPr/>
-        </p:nvSpPr>
-        <p:spPr>
-          <a:xfrm>
-            <a:off x="777240" y="9784080"/>
-            <a:ext cx="2697480" cy="365760"/>
-          </a:xfrm>
-          <a:prstGeom prst="rect">
-            <a:avLst/>
-          </a:prstGeom>
-          <a:noFill/>
-          <a:ln/>
-        </p:spPr>
-        <p:txBody>
-          <a:bodyPr wrap="square" lIns="0" tIns="0" rIns="0" bIns="0" rtlCol="0" anchor="t"/>
-          <a:lstStyle/>
-          <a:p>
-            <a:pPr indent="0" marL="0">
-              <a:buNone/>
-            </a:pPr>
-            <a:r>
-              <a:rPr lang="en-US" sz="950" dirty="0">
-                <a:solidFill>
-                  <a:srgbClr val="B5CCEC"/>
-                </a:solidFill>
-                <a:latin typeface="Poppins" pitchFamily="34" charset="0"/>
-                <a:ea typeface="Poppins" pitchFamily="34" charset="-122"/>
-                <a:cs typeface="Poppins" pitchFamily="34" charset="-120"/>
-              </a:rPr>
-              <a:t>Kostenlos, werbefrei, ohne Registrierung: Vertrauen färbt ab.</a:t>
-            </a:r>
-            <a:endParaRPr lang="en-US" sz="950" dirty="0"/>
-          </a:p>
-        </p:txBody>
-      </p:sp>
-      <p:sp>
-        <p:nvSpPr>
-          <p:cNvPr id="46" name="Text 43"/>
-          <p:cNvSpPr txBox="1"/>
-          <p:nvPr/>
-        </p:nvSpPr>
-        <p:spPr>
-          <a:xfrm>
-            <a:off x="4087368" y="9784080"/>
-            <a:ext cx="2697480" cy="365760"/>
-          </a:xfrm>
-          <a:prstGeom prst="rect">
-            <a:avLst/>
-          </a:prstGeom>
-          <a:noFill/>
-          <a:ln/>
-        </p:spPr>
-        <p:txBody>
-          <a:bodyPr wrap="square" lIns="0" tIns="0" rIns="0" bIns="0" rtlCol="0" anchor="t"/>
-          <a:lstStyle/>
-          <a:p>
-            <a:pPr indent="0" marL="0">
-              <a:buNone/>
-            </a:pPr>
-            <a:r>
-              <a:rPr lang="en-US" sz="950" dirty="0">
-                <a:solidFill>
-                  <a:srgbClr val="B5CCEC"/>
-                </a:solidFill>
-                <a:latin typeface="Poppins" pitchFamily="34" charset="0"/>
-                <a:ea typeface="Poppins" pitchFamily="34" charset="-122"/>
-                <a:cs typeface="Poppins" pitchFamily="34" charset="-120"/>
-              </a:rPr>
-              <a:t>Auf allen Seiten, während der gesamten Laufzeit.</a:t>
+              <a:t>Die Mathebox bleibt für Schulen kostenlos, auch dank Ihrer Unterstützung.</a:t>
             </a:r>
             <a:endParaRPr lang="en-US" sz="950" dirty="0"/>
           </a:p>
@@ -6416,7 +6397,7 @@
                 <a:ea typeface="Poppins" pitchFamily="34" charset="-122"/>
                 <a:cs typeface="Poppins" pitchFamily="34" charset="-120"/>
               </a:rPr>
-              <a:t>Preisvorschlag, über Laufzeit und Leistungen verhandelbar. 10 % Rabatt bei 2 Jahren Laufzeit.</a:t>
+              <a:t>Das Hauptsponsoring kostet 6.000 € für 12 Monate. 10 % Rabatt bei 2 Jahren Laufzeit.</a:t>
             </a:r>
             <a:endParaRPr lang="en-US" sz="1200" dirty="0"/>
           </a:p>

</xml_diff>